<commit_message>
Week 5 for loops edits
</commit_message>
<xml_diff>
--- a/lectures/week5/lecture3/slides/week5_lecture3.pptx
+++ b/lectures/week5/lecture3/slides/week5_lecture3.pptx
@@ -40,7 +40,7 @@
     <p:sldId id="266" r:id="rId34"/>
     <p:sldId id="344" r:id="rId35"/>
     <p:sldId id="386" r:id="rId36"/>
-    <p:sldId id="325" r:id="rId37"/>
+    <p:sldId id="387" r:id="rId37"/>
   </p:sldIdLst>
   <p:sldSz cx="12192000" cy="6858000"/>
   <p:notesSz cx="6858000" cy="9144000"/>
@@ -2091,7 +2091,7 @@
         <p:spPr>
           <a:xfrm>
             <a:off x="335947" y="5102715"/>
-            <a:ext cx="6619392" cy="1569660"/>
+            <a:ext cx="6619392" cy="1323439"/>
           </a:xfrm>
           <a:prstGeom prst="rect">
             <a:avLst/>
@@ -2153,36 +2153,6 @@
                 </a:solidFill>
               </a:rPr>
               <a:t>Online Term Test Review, Tuesday at 7:30 pm</a:t>
-            </a:r>
-            <a:r>
-              <a:rPr lang="en-US" sz="1600" dirty="0">
-                <a:solidFill>
-                  <a:srgbClr val="CC99FF"/>
-                </a:solidFill>
-              </a:rPr>
-              <a:t>.</a:t>
-            </a:r>
-            <a:endParaRPr lang="en-US" sz="1600" dirty="0">
-              <a:solidFill>
-                <a:srgbClr val="66FF99"/>
-              </a:solidFill>
-            </a:endParaRPr>
-          </a:p>
-          <a:p>
-            <a:pPr marL="285750" indent="-285750">
-              <a:buClr>
-                <a:srgbClr val="CC99FF"/>
-              </a:buClr>
-              <a:buFont typeface="Wingdings" panose="05000000000000000000" pitchFamily="2" charset="2"/>
-              <a:buChar char="§"/>
-            </a:pPr>
-            <a:r>
-              <a:rPr lang="en-US" sz="1600" dirty="0">
-                <a:solidFill>
-                  <a:srgbClr val="66FF99"/>
-                </a:solidFill>
-              </a:rPr>
-              <a:t>Lab 4 released 6:00 pm Thursday</a:t>
             </a:r>
             <a:r>
               <a:rPr lang="en-US" sz="1600" dirty="0">
@@ -7139,22 +7109,14 @@
                   <a:schemeClr val="accent1"/>
                 </a:solidFill>
               </a:rPr>
-              <a:t>6.1</a:t>
+              <a:t>5.1</a:t>
             </a:r>
           </a:p>
           <a:p>
             <a:pPr lvl="1"/>
             <a:r>
-              <a:rPr lang="en-US" b="1" dirty="0">
-                <a:solidFill>
-                  <a:schemeClr val="accent6"/>
-                </a:solidFill>
-              </a:rPr>
-              <a:t>for </a:t>
-            </a:r>
-            <a:r>
-              <a:rPr lang="en-US" b="1" dirty="0"/>
-              <a:t>loops</a:t>
+              <a:rPr lang="en-US" dirty="0"/>
+              <a:t>Strings: Conversions, Indexing, Slicing, and Immutability</a:t>
             </a:r>
           </a:p>
           <a:p>
@@ -7168,34 +7130,21 @@
                   <a:schemeClr val="accent1"/>
                 </a:solidFill>
               </a:rPr>
-              <a:t>6.2</a:t>
+              <a:t>5.2 </a:t>
             </a:r>
           </a:p>
           <a:p>
             <a:pPr lvl="1"/>
             <a:r>
-              <a:rPr lang="en-US" dirty="0">
-                <a:solidFill>
-                  <a:schemeClr val="accent6"/>
-                </a:solidFill>
-              </a:rPr>
-              <a:t>for </a:t>
-            </a:r>
-            <a:r>
               <a:rPr lang="en-US" dirty="0"/>
-              <a:t>loops on indices</a:t>
-            </a:r>
-            <a:r>
-              <a:rPr lang="en-US" dirty="0">
-                <a:solidFill>
-                  <a:schemeClr val="accent2"/>
-                </a:solidFill>
-              </a:rPr>
-              <a:t>,</a:t>
-            </a:r>
+              <a:t>Strings: practice exercise</a:t>
+            </a:r>
+          </a:p>
+          <a:p>
+            <a:pPr lvl="1"/>
             <a:r>
               <a:rPr lang="en-US" dirty="0"/>
-              <a:t> nested loops</a:t>
+              <a:t>Introduction to Object-Oriented Programming and the File Object</a:t>
             </a:r>
           </a:p>
           <a:p>
@@ -7209,26 +7158,30 @@
                   <a:schemeClr val="accent1"/>
                 </a:solidFill>
               </a:rPr>
-              <a:t>6.3</a:t>
+              <a:t>5.3</a:t>
             </a:r>
           </a:p>
           <a:p>
             <a:pPr lvl="1"/>
             <a:r>
-              <a:rPr lang="en-US" dirty="0"/>
-              <a:t>Design Problem</a:t>
-            </a:r>
-            <a:r>
-              <a:rPr lang="en-US" dirty="0">
-                <a:solidFill>
-                  <a:schemeClr val="accent1"/>
-                </a:solidFill>
-              </a:rPr>
-              <a:t>:</a:t>
-            </a:r>
-            <a:r>
-              <a:rPr lang="en-US" dirty="0"/>
-              <a:t> Cryptography</a:t>
+              <a:rPr lang="en-US" b="1" dirty="0">
+                <a:solidFill>
+                  <a:schemeClr val="accent6"/>
+                </a:solidFill>
+              </a:rPr>
+              <a:t>for </a:t>
+            </a:r>
+            <a:r>
+              <a:rPr lang="en-US" b="1" dirty="0"/>
+              <a:t>loops </a:t>
+            </a:r>
+            <a:r>
+              <a:rPr lang="en-US" b="1" dirty="0">
+                <a:solidFill>
+                  <a:srgbClr val="66FF99"/>
+                </a:solidFill>
+              </a:rPr>
+              <a:t>(Not on Term Test 1)</a:t>
             </a:r>
           </a:p>
         </p:txBody>
@@ -8158,7 +8111,9 @@
           </a:xfrm>
         </p:spPr>
         <p:txBody>
-          <a:bodyPr/>
+          <a:bodyPr>
+            <a:normAutofit lnSpcReduction="10000"/>
+          </a:bodyPr>
           <a:lstStyle/>
           <a:p>
             <a:r>
@@ -8306,6 +8261,14 @@
             <a:r>
               <a:rPr lang="en-US" dirty="0"/>
               <a:t> </a:t>
+            </a:r>
+            <a:r>
+              <a:rPr lang="en-US" dirty="0">
+                <a:solidFill>
+                  <a:srgbClr val="66FF99"/>
+                </a:solidFill>
+              </a:rPr>
+              <a:t>(not always natural though)</a:t>
             </a:r>
           </a:p>
           <a:p>
@@ -14192,7 +14155,13 @@
   <p:cSld>
     <p:spTree>
       <p:nvGrpSpPr>
-        <p:cNvPr id="1" name=""/>
+        <p:cNvPr id="1" name="">
+          <a:extLst>
+            <a:ext uri="{FF2B5EF4-FFF2-40B4-BE49-F238E27FC236}">
+              <a16:creationId xmlns:a16="http://schemas.microsoft.com/office/drawing/2014/main" id="{C7E2112A-07BC-8F69-C522-9271AD8912F0}"/>
+            </a:ext>
+          </a:extLst>
+        </p:cNvPr>
         <p:cNvGrpSpPr/>
         <p:nvPr/>
       </p:nvGrpSpPr>
@@ -14209,7 +14178,7 @@
           <p:cNvPr id="2" name="Title 1">
             <a:extLst>
               <a:ext uri="{FF2B5EF4-FFF2-40B4-BE49-F238E27FC236}">
-                <a16:creationId xmlns:a16="http://schemas.microsoft.com/office/drawing/2014/main" id="{057F06F2-AC3E-484E-9926-59D4F59092CE}"/>
+                <a16:creationId xmlns:a16="http://schemas.microsoft.com/office/drawing/2014/main" id="{87FB3E48-42D4-994B-F217-F8F01A84E842}"/>
               </a:ext>
             </a:extLst>
           </p:cNvPr>
@@ -14255,7 +14224,7 @@
           <p:cNvPr id="3" name="Subtitle 2">
             <a:extLst>
               <a:ext uri="{FF2B5EF4-FFF2-40B4-BE49-F238E27FC236}">
-                <a16:creationId xmlns:a16="http://schemas.microsoft.com/office/drawing/2014/main" id="{99B07687-F068-40FC-84A1-E7860490CACD}"/>
+                <a16:creationId xmlns:a16="http://schemas.microsoft.com/office/drawing/2014/main" id="{6B6F82D5-F847-D419-A747-64258E62BB70}"/>
               </a:ext>
             </a:extLst>
           </p:cNvPr>
@@ -14346,10 +14315,159 @@
           </a:p>
         </p:txBody>
       </p:sp>
+      <p:sp>
+        <p:nvSpPr>
+          <p:cNvPr id="4" name="TextBox 3">
+            <a:extLst>
+              <a:ext uri="{FF2B5EF4-FFF2-40B4-BE49-F238E27FC236}">
+                <a16:creationId xmlns:a16="http://schemas.microsoft.com/office/drawing/2014/main" id="{70DC444B-60E0-0BF6-D034-84C4212B800D}"/>
+              </a:ext>
+            </a:extLst>
+          </p:cNvPr>
+          <p:cNvSpPr txBox="1"/>
+          <p:nvPr/>
+        </p:nvSpPr>
+        <p:spPr>
+          <a:xfrm>
+            <a:off x="335947" y="5102715"/>
+            <a:ext cx="6619392" cy="1323439"/>
+          </a:xfrm>
+          <a:prstGeom prst="rect">
+            <a:avLst/>
+          </a:prstGeom>
+          <a:noFill/>
+        </p:spPr>
+        <p:txBody>
+          <a:bodyPr wrap="square" rtlCol="0">
+            <a:spAutoFit/>
+          </a:bodyPr>
+          <a:lstStyle/>
+          <a:p>
+            <a:r>
+              <a:rPr lang="en-US" sz="1600" b="1" dirty="0">
+                <a:solidFill>
+                  <a:srgbClr val="CC99FF"/>
+                </a:solidFill>
+              </a:rPr>
+              <a:t>Upcoming</a:t>
+            </a:r>
+          </a:p>
+          <a:p>
+            <a:pPr marL="285750" indent="-285750">
+              <a:buClr>
+                <a:srgbClr val="CC99FF"/>
+              </a:buClr>
+              <a:buFont typeface="Wingdings" panose="05000000000000000000" pitchFamily="2" charset="2"/>
+              <a:buChar char="§"/>
+            </a:pPr>
+            <a:r>
+              <a:rPr lang="en-US" sz="1600" dirty="0">
+                <a:solidFill>
+                  <a:srgbClr val="66FF99"/>
+                </a:solidFill>
+              </a:rPr>
+              <a:t>Term Test 1, Thursday at 7:00 pm</a:t>
+            </a:r>
+            <a:r>
+              <a:rPr lang="en-US" sz="1600" dirty="0">
+                <a:solidFill>
+                  <a:srgbClr val="CC99FF"/>
+                </a:solidFill>
+              </a:rPr>
+              <a:t>.</a:t>
+            </a:r>
+          </a:p>
+          <a:p>
+            <a:pPr marL="285750" indent="-285750">
+              <a:buClr>
+                <a:srgbClr val="CC99FF"/>
+              </a:buClr>
+              <a:buFont typeface="Wingdings" panose="05000000000000000000" pitchFamily="2" charset="2"/>
+              <a:buChar char="§"/>
+            </a:pPr>
+            <a:r>
+              <a:rPr lang="en-US" sz="1600" dirty="0">
+                <a:solidFill>
+                  <a:srgbClr val="66FF99"/>
+                </a:solidFill>
+              </a:rPr>
+              <a:t>Online Term Test Review, Tuesday at 7:30 pm</a:t>
+            </a:r>
+            <a:r>
+              <a:rPr lang="en-US" sz="1600" dirty="0">
+                <a:solidFill>
+                  <a:srgbClr val="CC99FF"/>
+                </a:solidFill>
+              </a:rPr>
+              <a:t>.</a:t>
+            </a:r>
+            <a:endParaRPr lang="en-US" sz="1600" dirty="0">
+              <a:solidFill>
+                <a:srgbClr val="66FF99"/>
+              </a:solidFill>
+            </a:endParaRPr>
+          </a:p>
+          <a:p>
+            <a:pPr marL="285750" indent="-285750">
+              <a:buClr>
+                <a:srgbClr val="CC99FF"/>
+              </a:buClr>
+              <a:buFont typeface="Wingdings" panose="05000000000000000000" pitchFamily="2" charset="2"/>
+              <a:buChar char="§"/>
+            </a:pPr>
+            <a:r>
+              <a:rPr lang="en-US" sz="1600" dirty="0">
+                <a:solidFill>
+                  <a:srgbClr val="66FF99"/>
+                </a:solidFill>
+              </a:rPr>
+              <a:t>Reflection 6 Released Friday 6:00 pm</a:t>
+            </a:r>
+            <a:r>
+              <a:rPr lang="en-US" sz="1600" dirty="0">
+                <a:solidFill>
+                  <a:srgbClr val="CC99FF"/>
+                </a:solidFill>
+              </a:rPr>
+              <a:t>.</a:t>
+            </a:r>
+            <a:endParaRPr lang="en-US" sz="1600" dirty="0">
+              <a:solidFill>
+                <a:srgbClr val="66FF99"/>
+              </a:solidFill>
+            </a:endParaRPr>
+          </a:p>
+          <a:p>
+            <a:pPr marL="285750" indent="-285750">
+              <a:buClr>
+                <a:srgbClr val="CC99FF"/>
+              </a:buClr>
+              <a:buFont typeface="Wingdings" panose="05000000000000000000" pitchFamily="2" charset="2"/>
+              <a:buChar char="§"/>
+            </a:pPr>
+            <a:r>
+              <a:rPr lang="en-US" sz="1600" dirty="0">
+                <a:solidFill>
+                  <a:srgbClr val="66FF99"/>
+                </a:solidFill>
+              </a:rPr>
+              <a:t>Tutorial (Online), Practical, Office Hour sessions running all week</a:t>
+            </a:r>
+            <a:r>
+              <a:rPr lang="en-US" sz="1600" dirty="0">
+                <a:solidFill>
+                  <a:srgbClr val="CC99FF"/>
+                </a:solidFill>
+              </a:rPr>
+              <a:t>.</a:t>
+            </a:r>
+          </a:p>
+        </p:txBody>
+      </p:sp>
     </p:spTree>
     <p:extLst>
       <p:ext uri="{BB962C8B-B14F-4D97-AF65-F5344CB8AC3E}">
-        <p14:creationId xmlns:p14="http://schemas.microsoft.com/office/powerpoint/2010/main" val="2860723679"/>
+        <p14:creationId xmlns:p14="http://schemas.microsoft.com/office/powerpoint/2010/main" val="3462600177"/>
       </p:ext>
     </p:extLst>
   </p:cSld>

</xml_diff>